<commit_message>
Corrected license information of slides
</commit_message>
<xml_diff>
--- a/slides/presentations/2024-10-18-seminar-upc.pptx
+++ b/slides/presentations/2024-10-18-seminar-upc.pptx
@@ -256,7 +256,7 @@
           <a:p>
             <a:fld id="{932107E3-02B0-4F32-9595-48F976375028}" type="datetimeFigureOut">
               <a:rPr lang="en-US" smtClean="0"/>
-              <a:t>4/13/2026</a:t>
+              <a:t>6/17/2026</a:t>
             </a:fld>
             <a:endParaRPr lang="en-US"/>
           </a:p>
@@ -7241,8 +7241,8 @@
         </p:nvSpPr>
         <p:spPr>
           <a:xfrm>
-            <a:off x="3248527" y="5851761"/>
-            <a:ext cx="8496237" cy="369332"/>
+            <a:off x="7038860" y="5851761"/>
+            <a:ext cx="4705904" cy="738664"/>
           </a:xfrm>
           <a:prstGeom prst="rect">
             <a:avLst/>
@@ -7255,20 +7255,51 @@
           </a:bodyPr>
           <a:lstStyle/>
           <a:p>
-            <a:r>
-              <a:rPr lang="en-US" dirty="0"/>
-              <a:t>Copyright © 2024 Julian Frattini. This work is licensed under the </a:t>
-            </a:r>
-            <a:r>
-              <a:rPr lang="en-US" dirty="0">
+            <a:pPr algn="r"/>
+            <a:r>
+              <a:rPr lang="en-US" sz="1400" dirty="0"/>
+              <a:t>Copyright © 2024 Julian Frattini. </a:t>
+            </a:r>
+            <a:endParaRPr lang="en-SE" sz="1400" dirty="0"/>
+          </a:p>
+          <a:p>
+            <a:pPr algn="r"/>
+            <a:r>
+              <a:rPr lang="en-US" sz="1400" dirty="0"/>
+              <a:t>The source code is licensed under the </a:t>
+            </a:r>
+            <a:r>
+              <a:rPr lang="en-SE" sz="1400" dirty="0">
                 <a:hlinkClick r:id="rId3"/>
               </a:rPr>
-              <a:t>Apache-2.0</a:t>
-            </a:r>
-            <a:r>
-              <a:rPr lang="en-US" dirty="0"/>
-              <a:t> License.</a:t>
-            </a:r>
+              <a:t>Apache License 2.0</a:t>
+            </a:r>
+            <a:r>
+              <a:rPr lang="en-US" sz="1400" dirty="0"/>
+              <a:t>.</a:t>
+            </a:r>
+          </a:p>
+          <a:p>
+            <a:pPr algn="r"/>
+            <a:r>
+              <a:rPr lang="en-US" sz="1400" dirty="0"/>
+              <a:t>This presentation is licensed under</a:t>
+            </a:r>
+            <a:r>
+              <a:rPr lang="en-SE" sz="1400" dirty="0"/>
+              <a:t> </a:t>
+            </a:r>
+            <a:r>
+              <a:rPr lang="de-DE" sz="1400" dirty="0">
+                <a:hlinkClick r:id="rId4"/>
+              </a:rPr>
+              <a:t>CC BY-NC-SA 4.0</a:t>
+            </a:r>
+            <a:r>
+              <a:rPr lang="en-SE" sz="1400"/>
+              <a:t>.</a:t>
+            </a:r>
+            <a:endParaRPr lang="en-US" sz="1400" dirty="0"/>
           </a:p>
         </p:txBody>
       </p:sp>
@@ -7327,7 +7358,7 @@
               <p:nvPr/>
             </p:nvPicPr>
             <p:blipFill>
-              <a:blip r:embed="rId4"/>
+              <a:blip r:embed="rId5"/>
               <a:stretch>
                 <a:fillRect/>
               </a:stretch>
@@ -7465,7 +7496,7 @@
         <p:sp>
           <p:nvSpPr>
             <p:cNvPr id="14" name="Rectangle 13">
-              <a:hlinkClick r:id="rId5"/>
+              <a:hlinkClick r:id="rId6"/>
               <a:extLst>
                 <a:ext uri="{FF2B5EF4-FFF2-40B4-BE49-F238E27FC236}">
                   <a16:creationId xmlns:a16="http://schemas.microsoft.com/office/drawing/2014/main" id="{6A8D6E86-922A-F18B-1057-285FBAABB067}"/>
@@ -12563,10 +12594,10 @@
             <p:nvPr/>
           </p:nvPicPr>
           <p:blipFill>
-            <a:blip r:embed="rId3">
+            <a:blip>
               <a:extLst>
                 <a:ext uri="{96DAC541-7B7A-43D3-8B79-37D633B846F1}">
-                  <asvg:svgBlip xmlns:asvg="http://schemas.microsoft.com/office/drawing/2016/SVG/main" r:embed="rId4"/>
+                  <asvg:svgBlip xmlns:asvg="http://schemas.microsoft.com/office/drawing/2016/SVG/main" r:embed="rId3"/>
                 </a:ext>
               </a:extLst>
             </a:blip>
@@ -12721,10 +12752,10 @@
             <p:nvPr/>
           </p:nvPicPr>
           <p:blipFill>
-            <a:blip r:embed="rId5">
+            <a:blip>
               <a:extLst>
                 <a:ext uri="{96DAC541-7B7A-43D3-8B79-37D633B846F1}">
-                  <asvg:svgBlip xmlns:asvg="http://schemas.microsoft.com/office/drawing/2016/SVG/main" r:embed="rId6"/>
+                  <asvg:svgBlip xmlns:asvg="http://schemas.microsoft.com/office/drawing/2016/SVG/main" r:embed="rId4"/>
                 </a:ext>
               </a:extLst>
             </a:blip>
@@ -12876,10 +12907,10 @@
             <p:nvPr/>
           </p:nvPicPr>
           <p:blipFill>
-            <a:blip r:embed="rId7">
+            <a:blip>
               <a:extLst>
                 <a:ext uri="{96DAC541-7B7A-43D3-8B79-37D633B846F1}">
-                  <asvg:svgBlip xmlns:asvg="http://schemas.microsoft.com/office/drawing/2016/SVG/main" r:embed="rId8"/>
+                  <asvg:svgBlip xmlns:asvg="http://schemas.microsoft.com/office/drawing/2016/SVG/main" r:embed="rId5"/>
                 </a:ext>
               </a:extLst>
             </a:blip>
@@ -17353,10 +17384,10 @@
             <p:nvPr/>
           </p:nvPicPr>
           <p:blipFill>
-            <a:blip r:embed="rId3">
+            <a:blip>
               <a:extLst>
                 <a:ext uri="{96DAC541-7B7A-43D3-8B79-37D633B846F1}">
-                  <asvg:svgBlip xmlns:asvg="http://schemas.microsoft.com/office/drawing/2016/SVG/main" r:embed="rId4"/>
+                  <asvg:svgBlip xmlns:asvg="http://schemas.microsoft.com/office/drawing/2016/SVG/main" r:embed="rId3"/>
                 </a:ext>
               </a:extLst>
             </a:blip>
@@ -17469,10 +17500,10 @@
             <p:nvPr/>
           </p:nvPicPr>
           <p:blipFill>
-            <a:blip r:embed="rId3">
+            <a:blip>
               <a:extLst>
                 <a:ext uri="{96DAC541-7B7A-43D3-8B79-37D633B846F1}">
-                  <asvg:svgBlip xmlns:asvg="http://schemas.microsoft.com/office/drawing/2016/SVG/main" r:embed="rId4"/>
+                  <asvg:svgBlip xmlns:asvg="http://schemas.microsoft.com/office/drawing/2016/SVG/main" r:embed="rId3"/>
                 </a:ext>
               </a:extLst>
             </a:blip>
@@ -17585,10 +17616,10 @@
             <p:nvPr/>
           </p:nvPicPr>
           <p:blipFill>
-            <a:blip r:embed="rId5">
+            <a:blip>
               <a:extLst>
                 <a:ext uri="{96DAC541-7B7A-43D3-8B79-37D633B846F1}">
-                  <asvg:svgBlip xmlns:asvg="http://schemas.microsoft.com/office/drawing/2016/SVG/main" r:embed="rId6"/>
+                  <asvg:svgBlip xmlns:asvg="http://schemas.microsoft.com/office/drawing/2016/SVG/main" r:embed="rId4"/>
                 </a:ext>
               </a:extLst>
             </a:blip>
@@ -17700,10 +17731,10 @@
             <p:nvPr/>
           </p:nvPicPr>
           <p:blipFill>
-            <a:blip r:embed="rId5">
+            <a:blip>
               <a:extLst>
                 <a:ext uri="{96DAC541-7B7A-43D3-8B79-37D633B846F1}">
-                  <asvg:svgBlip xmlns:asvg="http://schemas.microsoft.com/office/drawing/2016/SVG/main" r:embed="rId6"/>
+                  <asvg:svgBlip xmlns:asvg="http://schemas.microsoft.com/office/drawing/2016/SVG/main" r:embed="rId4"/>
                 </a:ext>
               </a:extLst>
             </a:blip>
@@ -17815,10 +17846,10 @@
             <p:nvPr/>
           </p:nvPicPr>
           <p:blipFill>
-            <a:blip r:embed="rId5">
+            <a:blip>
               <a:extLst>
                 <a:ext uri="{96DAC541-7B7A-43D3-8B79-37D633B846F1}">
-                  <asvg:svgBlip xmlns:asvg="http://schemas.microsoft.com/office/drawing/2016/SVG/main" r:embed="rId6"/>
+                  <asvg:svgBlip xmlns:asvg="http://schemas.microsoft.com/office/drawing/2016/SVG/main" r:embed="rId4"/>
                 </a:ext>
               </a:extLst>
             </a:blip>
@@ -17930,10 +17961,10 @@
             <p:nvPr/>
           </p:nvPicPr>
           <p:blipFill>
-            <a:blip r:embed="rId3">
+            <a:blip>
               <a:extLst>
                 <a:ext uri="{96DAC541-7B7A-43D3-8B79-37D633B846F1}">
-                  <asvg:svgBlip xmlns:asvg="http://schemas.microsoft.com/office/drawing/2016/SVG/main" r:embed="rId4"/>
+                  <asvg:svgBlip xmlns:asvg="http://schemas.microsoft.com/office/drawing/2016/SVG/main" r:embed="rId3"/>
                 </a:ext>
               </a:extLst>
             </a:blip>
@@ -23148,10 +23179,10 @@
             <p:nvPr/>
           </p:nvPicPr>
           <p:blipFill>
-            <a:blip r:embed="rId3">
+            <a:blip>
               <a:extLst>
                 <a:ext uri="{96DAC541-7B7A-43D3-8B79-37D633B846F1}">
-                  <asvg:svgBlip xmlns:asvg="http://schemas.microsoft.com/office/drawing/2016/SVG/main" r:embed="rId4"/>
+                  <asvg:svgBlip xmlns:asvg="http://schemas.microsoft.com/office/drawing/2016/SVG/main" r:embed="rId3"/>
                 </a:ext>
               </a:extLst>
             </a:blip>
@@ -23305,10 +23336,10 @@
             <p:nvPr/>
           </p:nvPicPr>
           <p:blipFill>
-            <a:blip r:embed="rId5">
+            <a:blip>
               <a:extLst>
                 <a:ext uri="{96DAC541-7B7A-43D3-8B79-37D633B846F1}">
-                  <asvg:svgBlip xmlns:asvg="http://schemas.microsoft.com/office/drawing/2016/SVG/main" r:embed="rId6"/>
+                  <asvg:svgBlip xmlns:asvg="http://schemas.microsoft.com/office/drawing/2016/SVG/main" r:embed="rId4"/>
                 </a:ext>
               </a:extLst>
             </a:blip>
@@ -23474,10 +23505,10 @@
             <p:nvPr/>
           </p:nvPicPr>
           <p:blipFill>
-            <a:blip r:embed="rId7">
+            <a:blip>
               <a:extLst>
                 <a:ext uri="{96DAC541-7B7A-43D3-8B79-37D633B846F1}">
-                  <asvg:svgBlip xmlns:asvg="http://schemas.microsoft.com/office/drawing/2016/SVG/main" r:embed="rId8"/>
+                  <asvg:svgBlip xmlns:asvg="http://schemas.microsoft.com/office/drawing/2016/SVG/main" r:embed="rId5"/>
                 </a:ext>
               </a:extLst>
             </a:blip>
@@ -23635,10 +23666,10 @@
             <p:nvPr/>
           </p:nvPicPr>
           <p:blipFill>
-            <a:blip r:embed="rId9">
+            <a:blip>
               <a:extLst>
                 <a:ext uri="{96DAC541-7B7A-43D3-8B79-37D633B846F1}">
-                  <asvg:svgBlip xmlns:asvg="http://schemas.microsoft.com/office/drawing/2016/SVG/main" r:embed="rId10"/>
+                  <asvg:svgBlip xmlns:asvg="http://schemas.microsoft.com/office/drawing/2016/SVG/main" r:embed="rId6"/>
                 </a:ext>
               </a:extLst>
             </a:blip>
@@ -25085,10 +25116,10 @@
               <p:nvPr/>
             </p:nvPicPr>
             <p:blipFill>
-              <a:blip r:embed="rId3">
+              <a:blip>
                 <a:extLst>
                   <a:ext uri="{96DAC541-7B7A-43D3-8B79-37D633B846F1}">
-                    <asvg:svgBlip xmlns:asvg="http://schemas.microsoft.com/office/drawing/2016/SVG/main" r:embed="rId4"/>
+                    <asvg:svgBlip xmlns:asvg="http://schemas.microsoft.com/office/drawing/2016/SVG/main" r:embed="rId3"/>
                   </a:ext>
                 </a:extLst>
               </a:blip>
@@ -25264,10 +25295,10 @@
               <p:nvPr/>
             </p:nvPicPr>
             <p:blipFill>
-              <a:blip r:embed="rId5">
+              <a:blip>
                 <a:extLst>
                   <a:ext uri="{96DAC541-7B7A-43D3-8B79-37D633B846F1}">
-                    <asvg:svgBlip xmlns:asvg="http://schemas.microsoft.com/office/drawing/2016/SVG/main" r:embed="rId6"/>
+                    <asvg:svgBlip xmlns:asvg="http://schemas.microsoft.com/office/drawing/2016/SVG/main" r:embed="rId4"/>
                   </a:ext>
                 </a:extLst>
               </a:blip>
@@ -25443,10 +25474,10 @@
               <p:nvPr/>
             </p:nvPicPr>
             <p:blipFill>
-              <a:blip r:embed="rId7">
+              <a:blip>
                 <a:extLst>
                   <a:ext uri="{96DAC541-7B7A-43D3-8B79-37D633B846F1}">
-                    <asvg:svgBlip xmlns:asvg="http://schemas.microsoft.com/office/drawing/2016/SVG/main" r:embed="rId8"/>
+                    <asvg:svgBlip xmlns:asvg="http://schemas.microsoft.com/office/drawing/2016/SVG/main" r:embed="rId5"/>
                   </a:ext>
                 </a:extLst>
               </a:blip>
@@ -29248,8 +29279,8 @@
           </a:fontRef>
         </p:style>
       </p:cxnSp>
-      <mc:AlternateContent xmlns:mc="http://schemas.openxmlformats.org/markup-compatibility/2006">
-        <mc:Choice xmlns:a14="http://schemas.microsoft.com/office/drawing/2010/main" Requires="a14">
+      <mc:AlternateContent xmlns:mc="http://schemas.openxmlformats.org/markup-compatibility/2006" xmlns:a14="http://schemas.microsoft.com/office/drawing/2010/main">
+        <mc:Choice Requires="a14">
           <p:sp>
             <p:nvSpPr>
               <p:cNvPr id="27" name="TextBox 26">
@@ -29278,6 +29309,7 @@
               </a:bodyPr>
               <a:lstStyle/>
               <a:p>
+                <a:pPr/>
                 <a14:m>
                   <m:oMathPara xmlns:m="http://schemas.openxmlformats.org/officeDocument/2006/math">
                     <m:oMathParaPr>
@@ -29310,7 +29342,7 @@
             </p:txBody>
           </p:sp>
         </mc:Choice>
-        <mc:Fallback>
+        <mc:Fallback xmlns="">
           <p:sp>
             <p:nvSpPr>
               <p:cNvPr id="27" name="TextBox 26">
@@ -29355,8 +29387,8 @@
           </p:sp>
         </mc:Fallback>
       </mc:AlternateContent>
-      <mc:AlternateContent xmlns:mc="http://schemas.openxmlformats.org/markup-compatibility/2006">
-        <mc:Choice xmlns:a14="http://schemas.microsoft.com/office/drawing/2010/main" Requires="a14">
+      <mc:AlternateContent xmlns:mc="http://schemas.openxmlformats.org/markup-compatibility/2006" xmlns:a14="http://schemas.microsoft.com/office/drawing/2010/main">
+        <mc:Choice Requires="a14">
           <p:sp>
             <p:nvSpPr>
               <p:cNvPr id="31" name="TextBox 30">
@@ -29385,6 +29417,7 @@
               </a:bodyPr>
               <a:lstStyle/>
               <a:p>
+                <a:pPr/>
                 <a14:m>
                   <m:oMathPara xmlns:m="http://schemas.openxmlformats.org/officeDocument/2006/math">
                     <m:oMathParaPr>
@@ -29461,7 +29494,7 @@
             </p:txBody>
           </p:sp>
         </mc:Choice>
-        <mc:Fallback>
+        <mc:Fallback xmlns="">
           <p:sp>
             <p:nvSpPr>
               <p:cNvPr id="31" name="TextBox 30">
@@ -29506,8 +29539,8 @@
           </p:sp>
         </mc:Fallback>
       </mc:AlternateContent>
-      <mc:AlternateContent xmlns:mc="http://schemas.openxmlformats.org/markup-compatibility/2006">
-        <mc:Choice xmlns:a14="http://schemas.microsoft.com/office/drawing/2010/main" Requires="a14">
+      <mc:AlternateContent xmlns:mc="http://schemas.openxmlformats.org/markup-compatibility/2006" xmlns:a14="http://schemas.microsoft.com/office/drawing/2010/main">
+        <mc:Choice Requires="a14">
           <p:sp>
             <p:nvSpPr>
               <p:cNvPr id="32" name="TextBox 31">
@@ -29536,6 +29569,7 @@
               </a:bodyPr>
               <a:lstStyle/>
               <a:p>
+                <a:pPr/>
                 <a14:m>
                   <m:oMathPara xmlns:m="http://schemas.openxmlformats.org/officeDocument/2006/math">
                     <m:oMathParaPr>
@@ -29562,7 +29596,7 @@
             </p:txBody>
           </p:sp>
         </mc:Choice>
-        <mc:Fallback>
+        <mc:Fallback xmlns="">
           <p:sp>
             <p:nvSpPr>
               <p:cNvPr id="32" name="TextBox 31">
@@ -29607,8 +29641,8 @@
           </p:sp>
         </mc:Fallback>
       </mc:AlternateContent>
-      <mc:AlternateContent xmlns:mc="http://schemas.openxmlformats.org/markup-compatibility/2006">
-        <mc:Choice xmlns:a14="http://schemas.microsoft.com/office/drawing/2010/main" Requires="a14">
+      <mc:AlternateContent xmlns:mc="http://schemas.openxmlformats.org/markup-compatibility/2006" xmlns:a14="http://schemas.microsoft.com/office/drawing/2010/main">
+        <mc:Choice Requires="a14">
           <p:sp>
             <p:nvSpPr>
               <p:cNvPr id="33" name="TextBox 32">
@@ -29637,6 +29671,7 @@
               </a:bodyPr>
               <a:lstStyle/>
               <a:p>
+                <a:pPr/>
                 <a14:m>
                   <m:oMathPara xmlns:m="http://schemas.openxmlformats.org/officeDocument/2006/math">
                     <m:oMathParaPr>
@@ -29751,7 +29786,7 @@
             </p:txBody>
           </p:sp>
         </mc:Choice>
-        <mc:Fallback>
+        <mc:Fallback xmlns="">
           <p:sp>
             <p:nvSpPr>
               <p:cNvPr id="33" name="TextBox 32">
@@ -29839,8 +29874,8 @@
           </a:fontRef>
         </p:style>
       </p:cxnSp>
-      <mc:AlternateContent xmlns:mc="http://schemas.openxmlformats.org/markup-compatibility/2006">
-        <mc:Choice xmlns:a14="http://schemas.microsoft.com/office/drawing/2010/main" Requires="a14">
+      <mc:AlternateContent xmlns:mc="http://schemas.openxmlformats.org/markup-compatibility/2006" xmlns:a14="http://schemas.microsoft.com/office/drawing/2010/main">
+        <mc:Choice Requires="a14">
           <p:sp>
             <p:nvSpPr>
               <p:cNvPr id="39" name="TextBox 38">
@@ -29869,6 +29904,7 @@
               </a:bodyPr>
               <a:lstStyle/>
               <a:p>
+                <a:pPr/>
                 <a14:m>
                   <m:oMathPara xmlns:m="http://schemas.openxmlformats.org/officeDocument/2006/math">
                     <m:oMathParaPr>
@@ -29920,7 +29956,7 @@
             </p:txBody>
           </p:sp>
         </mc:Choice>
-        <mc:Fallback>
+        <mc:Fallback xmlns="">
           <p:sp>
             <p:nvSpPr>
               <p:cNvPr id="39" name="TextBox 38">
@@ -29965,8 +30001,8 @@
           </p:sp>
         </mc:Fallback>
       </mc:AlternateContent>
-      <mc:AlternateContent xmlns:mc="http://schemas.openxmlformats.org/markup-compatibility/2006">
-        <mc:Choice xmlns:a14="http://schemas.microsoft.com/office/drawing/2010/main" Requires="a14">
+      <mc:AlternateContent xmlns:mc="http://schemas.openxmlformats.org/markup-compatibility/2006" xmlns:a14="http://schemas.microsoft.com/office/drawing/2010/main">
+        <mc:Choice Requires="a14">
           <p:sp>
             <p:nvSpPr>
               <p:cNvPr id="40" name="TextBox 39">
@@ -29995,6 +30031,7 @@
               </a:bodyPr>
               <a:lstStyle/>
               <a:p>
+                <a:pPr/>
                 <a14:m>
                   <m:oMathPara xmlns:m="http://schemas.openxmlformats.org/officeDocument/2006/math">
                     <m:oMathParaPr>
@@ -30021,7 +30058,7 @@
             </p:txBody>
           </p:sp>
         </mc:Choice>
-        <mc:Fallback>
+        <mc:Fallback xmlns="">
           <p:sp>
             <p:nvSpPr>
               <p:cNvPr id="40" name="TextBox 39">
@@ -30109,8 +30146,8 @@
           </a:fontRef>
         </p:style>
       </p:cxnSp>
-      <mc:AlternateContent xmlns:mc="http://schemas.openxmlformats.org/markup-compatibility/2006">
-        <mc:Choice xmlns:a14="http://schemas.microsoft.com/office/drawing/2010/main" Requires="a14">
+      <mc:AlternateContent xmlns:mc="http://schemas.openxmlformats.org/markup-compatibility/2006" xmlns:a14="http://schemas.microsoft.com/office/drawing/2010/main">
+        <mc:Choice Requires="a14">
           <p:sp>
             <p:nvSpPr>
               <p:cNvPr id="45" name="TextBox 44">
@@ -30139,6 +30176,7 @@
               </a:bodyPr>
               <a:lstStyle/>
               <a:p>
+                <a:pPr/>
                 <a14:m>
                   <m:oMathPara xmlns:m="http://schemas.openxmlformats.org/officeDocument/2006/math">
                     <m:oMathParaPr>
@@ -30171,7 +30209,7 @@
             </p:txBody>
           </p:sp>
         </mc:Choice>
-        <mc:Fallback>
+        <mc:Fallback xmlns="">
           <p:sp>
             <p:nvSpPr>
               <p:cNvPr id="45" name="TextBox 44">
@@ -30216,8 +30254,8 @@
           </p:sp>
         </mc:Fallback>
       </mc:AlternateContent>
-      <mc:AlternateContent xmlns:mc="http://schemas.openxmlformats.org/markup-compatibility/2006">
-        <mc:Choice xmlns:a14="http://schemas.microsoft.com/office/drawing/2010/main" Requires="a14">
+      <mc:AlternateContent xmlns:mc="http://schemas.openxmlformats.org/markup-compatibility/2006" xmlns:a14="http://schemas.microsoft.com/office/drawing/2010/main">
+        <mc:Choice Requires="a14">
           <p:sp>
             <p:nvSpPr>
               <p:cNvPr id="46" name="TextBox 45">
@@ -30246,6 +30284,7 @@
               </a:bodyPr>
               <a:lstStyle/>
               <a:p>
+                <a:pPr/>
                 <a14:m>
                   <m:oMathPara xmlns:m="http://schemas.openxmlformats.org/officeDocument/2006/math">
                     <m:oMathParaPr>
@@ -30315,7 +30354,7 @@
             </p:txBody>
           </p:sp>
         </mc:Choice>
-        <mc:Fallback>
+        <mc:Fallback xmlns="">
           <p:sp>
             <p:nvSpPr>
               <p:cNvPr id="46" name="TextBox 45">
@@ -30360,8 +30399,8 @@
           </p:sp>
         </mc:Fallback>
       </mc:AlternateContent>
-      <mc:AlternateContent xmlns:mc="http://schemas.openxmlformats.org/markup-compatibility/2006">
-        <mc:Choice xmlns:a14="http://schemas.microsoft.com/office/drawing/2010/main" Requires="a14">
+      <mc:AlternateContent xmlns:mc="http://schemas.openxmlformats.org/markup-compatibility/2006" xmlns:a14="http://schemas.microsoft.com/office/drawing/2010/main">
+        <mc:Choice Requires="a14">
           <p:sp>
             <p:nvSpPr>
               <p:cNvPr id="47" name="TextBox 46">
@@ -30390,6 +30429,7 @@
               </a:bodyPr>
               <a:lstStyle/>
               <a:p>
+                <a:pPr/>
                 <a14:m>
                   <m:oMathPara xmlns:m="http://schemas.openxmlformats.org/officeDocument/2006/math">
                     <m:oMathParaPr>
@@ -30416,7 +30456,7 @@
             </p:txBody>
           </p:sp>
         </mc:Choice>
-        <mc:Fallback>
+        <mc:Fallback xmlns="">
           <p:sp>
             <p:nvSpPr>
               <p:cNvPr id="47" name="TextBox 46">
@@ -30502,8 +30542,8 @@
           </a:fontRef>
         </p:style>
       </p:cxnSp>
-      <mc:AlternateContent xmlns:mc="http://schemas.openxmlformats.org/markup-compatibility/2006">
-        <mc:Choice xmlns:a14="http://schemas.microsoft.com/office/drawing/2010/main" Requires="a14">
+      <mc:AlternateContent xmlns:mc="http://schemas.openxmlformats.org/markup-compatibility/2006" xmlns:a14="http://schemas.microsoft.com/office/drawing/2010/main">
+        <mc:Choice Requires="a14">
           <p:sp>
             <p:nvSpPr>
               <p:cNvPr id="52" name="TextBox 51">
@@ -30532,6 +30572,7 @@
               </a:bodyPr>
               <a:lstStyle/>
               <a:p>
+                <a:pPr/>
                 <a14:m>
                   <m:oMathPara xmlns:m="http://schemas.openxmlformats.org/officeDocument/2006/math">
                     <m:oMathParaPr>
@@ -30564,7 +30605,7 @@
             </p:txBody>
           </p:sp>
         </mc:Choice>
-        <mc:Fallback>
+        <mc:Fallback xmlns="">
           <p:sp>
             <p:nvSpPr>
               <p:cNvPr id="52" name="TextBox 51">
@@ -30609,8 +30650,8 @@
           </p:sp>
         </mc:Fallback>
       </mc:AlternateContent>
-      <mc:AlternateContent xmlns:mc="http://schemas.openxmlformats.org/markup-compatibility/2006">
-        <mc:Choice xmlns:a14="http://schemas.microsoft.com/office/drawing/2010/main" Requires="a14">
+      <mc:AlternateContent xmlns:mc="http://schemas.openxmlformats.org/markup-compatibility/2006" xmlns:a14="http://schemas.microsoft.com/office/drawing/2010/main">
+        <mc:Choice Requires="a14">
           <p:sp>
             <p:nvSpPr>
               <p:cNvPr id="53" name="TextBox 52">
@@ -30639,6 +30680,7 @@
               </a:bodyPr>
               <a:lstStyle/>
               <a:p>
+                <a:pPr/>
                 <a14:m>
                   <m:oMathPara xmlns:m="http://schemas.openxmlformats.org/officeDocument/2006/math">
                     <m:oMathParaPr>
@@ -30665,7 +30707,7 @@
             </p:txBody>
           </p:sp>
         </mc:Choice>
-        <mc:Fallback>
+        <mc:Fallback xmlns="">
           <p:sp>
             <p:nvSpPr>
               <p:cNvPr id="53" name="TextBox 52">
@@ -31003,10 +31045,10 @@
               <p:nvPr/>
             </p:nvPicPr>
             <p:blipFill>
-              <a:blip r:embed="rId3">
+              <a:blip>
                 <a:extLst>
                   <a:ext uri="{96DAC541-7B7A-43D3-8B79-37D633B846F1}">
-                    <asvg:svgBlip xmlns:asvg="http://schemas.microsoft.com/office/drawing/2016/SVG/main" r:embed="rId4"/>
+                    <asvg:svgBlip xmlns:asvg="http://schemas.microsoft.com/office/drawing/2016/SVG/main" r:embed="rId3"/>
                   </a:ext>
                 </a:extLst>
               </a:blip>
@@ -31175,10 +31217,10 @@
               <p:nvPr/>
             </p:nvPicPr>
             <p:blipFill>
-              <a:blip r:embed="rId5">
+              <a:blip>
                 <a:extLst>
                   <a:ext uri="{96DAC541-7B7A-43D3-8B79-37D633B846F1}">
-                    <asvg:svgBlip xmlns:asvg="http://schemas.microsoft.com/office/drawing/2016/SVG/main" r:embed="rId6"/>
+                    <asvg:svgBlip xmlns:asvg="http://schemas.microsoft.com/office/drawing/2016/SVG/main" r:embed="rId4"/>
                   </a:ext>
                 </a:extLst>
               </a:blip>
@@ -33962,10 +34004,10 @@
             <p:nvPr/>
           </p:nvPicPr>
           <p:blipFill>
-            <a:blip r:embed="rId3">
+            <a:blip>
               <a:extLst>
                 <a:ext uri="{96DAC541-7B7A-43D3-8B79-37D633B846F1}">
-                  <asvg:svgBlip xmlns:asvg="http://schemas.microsoft.com/office/drawing/2016/SVG/main" r:embed="rId4"/>
+                  <asvg:svgBlip xmlns:asvg="http://schemas.microsoft.com/office/drawing/2016/SVG/main" r:embed="rId3"/>
                 </a:ext>
               </a:extLst>
             </a:blip>
@@ -34119,10 +34161,10 @@
             <p:nvPr/>
           </p:nvPicPr>
           <p:blipFill>
-            <a:blip r:embed="rId5">
+            <a:blip>
               <a:extLst>
                 <a:ext uri="{96DAC541-7B7A-43D3-8B79-37D633B846F1}">
-                  <asvg:svgBlip xmlns:asvg="http://schemas.microsoft.com/office/drawing/2016/SVG/main" r:embed="rId6"/>
+                  <asvg:svgBlip xmlns:asvg="http://schemas.microsoft.com/office/drawing/2016/SVG/main" r:embed="rId4"/>
                 </a:ext>
               </a:extLst>
             </a:blip>
@@ -34276,10 +34318,10 @@
             <p:nvPr/>
           </p:nvPicPr>
           <p:blipFill>
-            <a:blip r:embed="rId7">
+            <a:blip>
               <a:extLst>
                 <a:ext uri="{96DAC541-7B7A-43D3-8B79-37D633B846F1}">
-                  <asvg:svgBlip xmlns:asvg="http://schemas.microsoft.com/office/drawing/2016/SVG/main" r:embed="rId8"/>
+                  <asvg:svgBlip xmlns:asvg="http://schemas.microsoft.com/office/drawing/2016/SVG/main" r:embed="rId5"/>
                 </a:ext>
               </a:extLst>
             </a:blip>
@@ -34910,10 +34952,10 @@
             <p:nvPr/>
           </p:nvPicPr>
           <p:blipFill>
-            <a:blip r:embed="rId3">
+            <a:blip>
               <a:extLst>
                 <a:ext uri="{96DAC541-7B7A-43D3-8B79-37D633B846F1}">
-                  <asvg:svgBlip xmlns:asvg="http://schemas.microsoft.com/office/drawing/2016/SVG/main" r:embed="rId4"/>
+                  <asvg:svgBlip xmlns:asvg="http://schemas.microsoft.com/office/drawing/2016/SVG/main" r:embed="rId3"/>
                 </a:ext>
               </a:extLst>
             </a:blip>
@@ -35014,10 +35056,10 @@
             <p:nvPr/>
           </p:nvPicPr>
           <p:blipFill>
-            <a:blip r:embed="rId3">
+            <a:blip>
               <a:extLst>
                 <a:ext uri="{96DAC541-7B7A-43D3-8B79-37D633B846F1}">
-                  <asvg:svgBlip xmlns:asvg="http://schemas.microsoft.com/office/drawing/2016/SVG/main" r:embed="rId4"/>
+                  <asvg:svgBlip xmlns:asvg="http://schemas.microsoft.com/office/drawing/2016/SVG/main" r:embed="rId3"/>
                 </a:ext>
               </a:extLst>
             </a:blip>
@@ -35118,10 +35160,10 @@
             <p:nvPr/>
           </p:nvPicPr>
           <p:blipFill>
-            <a:blip r:embed="rId5">
+            <a:blip>
               <a:extLst>
                 <a:ext uri="{96DAC541-7B7A-43D3-8B79-37D633B846F1}">
-                  <asvg:svgBlip xmlns:asvg="http://schemas.microsoft.com/office/drawing/2016/SVG/main" r:embed="rId6"/>
+                  <asvg:svgBlip xmlns:asvg="http://schemas.microsoft.com/office/drawing/2016/SVG/main" r:embed="rId4"/>
                 </a:ext>
               </a:extLst>
             </a:blip>
@@ -35230,10 +35272,10 @@
             <p:nvPr/>
           </p:nvPicPr>
           <p:blipFill>
-            <a:blip r:embed="rId5">
+            <a:blip>
               <a:extLst>
                 <a:ext uri="{96DAC541-7B7A-43D3-8B79-37D633B846F1}">
-                  <asvg:svgBlip xmlns:asvg="http://schemas.microsoft.com/office/drawing/2016/SVG/main" r:embed="rId6"/>
+                  <asvg:svgBlip xmlns:asvg="http://schemas.microsoft.com/office/drawing/2016/SVG/main" r:embed="rId4"/>
                 </a:ext>
               </a:extLst>
             </a:blip>
@@ -35358,10 +35400,10 @@
             <p:nvPr/>
           </p:nvPicPr>
           <p:blipFill>
-            <a:blip r:embed="rId5">
+            <a:blip>
               <a:extLst>
                 <a:ext uri="{96DAC541-7B7A-43D3-8B79-37D633B846F1}">
-                  <asvg:svgBlip xmlns:asvg="http://schemas.microsoft.com/office/drawing/2016/SVG/main" r:embed="rId6"/>
+                  <asvg:svgBlip xmlns:asvg="http://schemas.microsoft.com/office/drawing/2016/SVG/main" r:embed="rId4"/>
                 </a:ext>
               </a:extLst>
             </a:blip>

</xml_diff>